<commit_message>
SIK & PRC flag fix
</commit_message>
<xml_diff>
--- a/HoI4/SCP_EQ_Tools/SCP_EQ_Tools/_SCP_EQ_Tools_assets/CHI_Flag.pptx
+++ b/HoI4/SCP_EQ_Tools/SCP_EQ_Tools/_SCP_EQ_Tools_assets/CHI_Flag.pptx
@@ -5,7 +5,7 @@
     <p:sldMasterId id="2147483660" r:id="rId1"/>
   </p:sldMasterIdLst>
   <p:notesMasterIdLst>
-    <p:notesMasterId r:id="rId18"/>
+    <p:notesMasterId r:id="rId17"/>
   </p:notesMasterIdLst>
   <p:sldIdLst>
     <p:sldId id="256" r:id="rId2"/>
@@ -18,12 +18,11 @@
     <p:sldId id="267" r:id="rId9"/>
     <p:sldId id="269" r:id="rId10"/>
     <p:sldId id="270" r:id="rId11"/>
-    <p:sldId id="271" r:id="rId12"/>
-    <p:sldId id="268" r:id="rId13"/>
-    <p:sldId id="257" r:id="rId14"/>
-    <p:sldId id="258" r:id="rId15"/>
-    <p:sldId id="259" r:id="rId16"/>
-    <p:sldId id="260" r:id="rId17"/>
+    <p:sldId id="268" r:id="rId12"/>
+    <p:sldId id="257" r:id="rId13"/>
+    <p:sldId id="258" r:id="rId14"/>
+    <p:sldId id="259" r:id="rId15"/>
+    <p:sldId id="260" r:id="rId16"/>
   </p:sldIdLst>
   <p:sldSz cx="10814050" cy="6858000"/>
   <p:notesSz cx="6858000" cy="9144000"/>
@@ -651,11 +650,8 @@
             </a:pPr>
             <a:r>
               <a:rPr lang="en-US" altLang="zh-CN" smtClean="0"/>
-              <a:t>HoI4 national flag size: 82x52, 41x26, 10x7</a:t>
+              <a:t>SIK: https://zhuanlan.zhihu.com/p/588894093?utm_psn=1828649422269059072</a:t>
             </a:r>
-            <a:endParaRPr lang="zh-CN" altLang="en-US" smtClean="0"/>
-          </a:p>
-          <a:p>
             <a:endParaRPr lang="zh-CN" altLang="en-US"/>
           </a:p>
         </p:txBody>
@@ -786,114 +782,6 @@
             <a:fld id="{C41E944E-3654-452D-9BBA-0D643D0DFAC8}" type="slidenum">
               <a:rPr lang="zh-CN" altLang="en-US" smtClean="0"/>
               <a:t>11</a:t>
-            </a:fld>
-            <a:endParaRPr lang="zh-CN" altLang="en-US"/>
-          </a:p>
-        </p:txBody>
-      </p:sp>
-    </p:spTree>
-    <p:extLst>
-      <p:ext uri="{BB962C8B-B14F-4D97-AF65-F5344CB8AC3E}">
-        <p14:creationId xmlns:p14="http://schemas.microsoft.com/office/powerpoint/2010/main" val="3779381602"/>
-      </p:ext>
-    </p:extLst>
-  </p:cSld>
-  <p:clrMapOvr>
-    <a:masterClrMapping/>
-  </p:clrMapOvr>
-</p:notes>
-</file>
-
-<file path=ppt/notesSlides/notesSlide12.xml><?xml version="1.0" encoding="utf-8"?>
-<p:notes xmlns:a="http://schemas.openxmlformats.org/drawingml/2006/main" xmlns:r="http://schemas.openxmlformats.org/officeDocument/2006/relationships" xmlns:p="http://schemas.openxmlformats.org/presentationml/2006/main">
-  <p:cSld>
-    <p:spTree>
-      <p:nvGrpSpPr>
-        <p:cNvPr id="1" name=""/>
-        <p:cNvGrpSpPr/>
-        <p:nvPr/>
-      </p:nvGrpSpPr>
-      <p:grpSpPr>
-        <a:xfrm>
-          <a:off x="0" y="0"/>
-          <a:ext cx="0" cy="0"/>
-          <a:chOff x="0" y="0"/>
-          <a:chExt cx="0" cy="0"/>
-        </a:xfrm>
-      </p:grpSpPr>
-      <p:sp>
-        <p:nvSpPr>
-          <p:cNvPr id="2" name="投影片圖像版面配置區 1"/>
-          <p:cNvSpPr>
-            <a:spLocks noGrp="1" noRot="1" noChangeAspect="1"/>
-          </p:cNvSpPr>
-          <p:nvPr>
-            <p:ph type="sldImg"/>
-          </p:nvPr>
-        </p:nvSpPr>
-        <p:spPr/>
-      </p:sp>
-      <p:sp>
-        <p:nvSpPr>
-          <p:cNvPr id="3" name="備忘稿版面配置區 2"/>
-          <p:cNvSpPr>
-            <a:spLocks noGrp="1"/>
-          </p:cNvSpPr>
-          <p:nvPr>
-            <p:ph type="body" idx="1"/>
-          </p:nvPr>
-        </p:nvSpPr>
-        <p:spPr/>
-        <p:txBody>
-          <a:bodyPr/>
-          <a:lstStyle/>
-          <a:p>
-            <a:pPr marL="0" marR="0" lvl="0" indent="0" algn="l" defTabSz="914400" rtl="0" eaLnBrk="1" fontAlgn="auto" latinLnBrk="0" hangingPunct="1">
-              <a:lnSpc>
-                <a:spcPct val="100000"/>
-              </a:lnSpc>
-              <a:spcBef>
-                <a:spcPts val="0"/>
-              </a:spcBef>
-              <a:spcAft>
-                <a:spcPts val="0"/>
-              </a:spcAft>
-              <a:buClrTx/>
-              <a:buSzTx/>
-              <a:buFontTx/>
-              <a:buNone/>
-              <a:tabLst/>
-              <a:defRPr/>
-            </a:pPr>
-            <a:r>
-              <a:rPr lang="en-US" altLang="zh-CN" smtClean="0"/>
-              <a:t>HoI4 national flag size: 82x52, 41x26, 10x7</a:t>
-            </a:r>
-            <a:endParaRPr lang="zh-CN" altLang="en-US" smtClean="0"/>
-          </a:p>
-          <a:p>
-            <a:endParaRPr lang="zh-CN" altLang="en-US"/>
-          </a:p>
-        </p:txBody>
-      </p:sp>
-      <p:sp>
-        <p:nvSpPr>
-          <p:cNvPr id="4" name="投影片編號版面配置區 3"/>
-          <p:cNvSpPr>
-            <a:spLocks noGrp="1"/>
-          </p:cNvSpPr>
-          <p:nvPr>
-            <p:ph type="sldNum" sz="quarter" idx="10"/>
-          </p:nvPr>
-        </p:nvSpPr>
-        <p:spPr/>
-        <p:txBody>
-          <a:bodyPr/>
-          <a:lstStyle/>
-          <a:p>
-            <a:fld id="{C41E944E-3654-452D-9BBA-0D643D0DFAC8}" type="slidenum">
-              <a:rPr lang="zh-CN" altLang="en-US" smtClean="0"/>
-              <a:t>12</a:t>
             </a:fld>
             <a:endParaRPr lang="zh-CN" altLang="en-US"/>
           </a:p>
@@ -5447,7 +5335,7 @@
             <a:avLst/>
           </a:prstGeom>
           <a:solidFill>
-            <a:srgbClr val="FFFF00"/>
+            <a:srgbClr val="C00000"/>
           </a:solidFill>
           <a:ln w="19050">
             <a:noFill/>
@@ -5486,14 +5374,14 @@
         </p:nvSpPr>
         <p:spPr>
           <a:xfrm>
-            <a:off x="627962" y="627962"/>
-            <a:ext cx="2324559" cy="2622015"/>
+            <a:off x="710678" y="727113"/>
+            <a:ext cx="2155842" cy="2445745"/>
           </a:xfrm>
           <a:prstGeom prst="star6">
             <a:avLst/>
           </a:prstGeom>
           <a:solidFill>
-            <a:srgbClr val="FF0000"/>
+            <a:srgbClr val="FFC000"/>
           </a:solidFill>
           <a:ln>
             <a:noFill/>
@@ -5538,128 +5426,6 @@
 </file>
 
 <file path=ppt/slides/slide11.xml><?xml version="1.0" encoding="utf-8"?>
-<p:sld xmlns:a="http://schemas.openxmlformats.org/drawingml/2006/main" xmlns:r="http://schemas.openxmlformats.org/officeDocument/2006/relationships" xmlns:p="http://schemas.openxmlformats.org/presentationml/2006/main">
-  <p:cSld>
-    <p:spTree>
-      <p:nvGrpSpPr>
-        <p:cNvPr id="1" name=""/>
-        <p:cNvGrpSpPr/>
-        <p:nvPr/>
-      </p:nvGrpSpPr>
-      <p:grpSpPr>
-        <a:xfrm>
-          <a:off x="0" y="0"/>
-          <a:ext cx="0" cy="0"/>
-          <a:chOff x="0" y="0"/>
-          <a:chExt cx="0" cy="0"/>
-        </a:xfrm>
-      </p:grpSpPr>
-      <p:sp>
-        <p:nvSpPr>
-          <p:cNvPr id="4" name="矩形 3"/>
-          <p:cNvSpPr/>
-          <p:nvPr/>
-        </p:nvSpPr>
-        <p:spPr>
-          <a:xfrm>
-            <a:off x="0" y="0"/>
-            <a:ext cx="10814050" cy="6858000"/>
-          </a:xfrm>
-          <a:prstGeom prst="rect">
-            <a:avLst/>
-          </a:prstGeom>
-          <a:solidFill>
-            <a:srgbClr val="FE0000"/>
-          </a:solidFill>
-          <a:ln w="19050">
-            <a:noFill/>
-          </a:ln>
-        </p:spPr>
-        <p:style>
-          <a:lnRef idx="2">
-            <a:schemeClr val="accent1">
-              <a:shade val="50000"/>
-            </a:schemeClr>
-          </a:lnRef>
-          <a:fillRef idx="1">
-            <a:schemeClr val="accent1"/>
-          </a:fillRef>
-          <a:effectRef idx="0">
-            <a:schemeClr val="accent1"/>
-          </a:effectRef>
-          <a:fontRef idx="minor">
-            <a:schemeClr val="lt1"/>
-          </a:fontRef>
-        </p:style>
-        <p:txBody>
-          <a:bodyPr rtlCol="0" anchor="ctr"/>
-          <a:lstStyle/>
-          <a:p>
-            <a:pPr algn="ctr"/>
-            <a:endParaRPr lang="zh-CN" altLang="en-US"/>
-          </a:p>
-        </p:txBody>
-      </p:sp>
-      <p:sp>
-        <p:nvSpPr>
-          <p:cNvPr id="3" name="六角星形 2"/>
-          <p:cNvSpPr/>
-          <p:nvPr/>
-        </p:nvSpPr>
-        <p:spPr>
-          <a:xfrm>
-            <a:off x="3877307" y="1703535"/>
-            <a:ext cx="3059437" cy="3450930"/>
-          </a:xfrm>
-          <a:prstGeom prst="star6">
-            <a:avLst/>
-          </a:prstGeom>
-          <a:solidFill>
-            <a:srgbClr val="FFFF00"/>
-          </a:solidFill>
-          <a:ln>
-            <a:noFill/>
-          </a:ln>
-        </p:spPr>
-        <p:style>
-          <a:lnRef idx="2">
-            <a:schemeClr val="accent1">
-              <a:shade val="50000"/>
-            </a:schemeClr>
-          </a:lnRef>
-          <a:fillRef idx="1">
-            <a:schemeClr val="accent1"/>
-          </a:fillRef>
-          <a:effectRef idx="0">
-            <a:schemeClr val="accent1"/>
-          </a:effectRef>
-          <a:fontRef idx="minor">
-            <a:schemeClr val="lt1"/>
-          </a:fontRef>
-        </p:style>
-        <p:txBody>
-          <a:bodyPr rtlCol="0" anchor="ctr"/>
-          <a:lstStyle/>
-          <a:p>
-            <a:pPr algn="ctr"/>
-            <a:endParaRPr lang="zh-CN" altLang="en-US"/>
-          </a:p>
-        </p:txBody>
-      </p:sp>
-    </p:spTree>
-    <p:extLst>
-      <p:ext uri="{BB962C8B-B14F-4D97-AF65-F5344CB8AC3E}">
-        <p14:creationId xmlns:p14="http://schemas.microsoft.com/office/powerpoint/2010/main" val="2074972481"/>
-      </p:ext>
-    </p:extLst>
-  </p:cSld>
-  <p:clrMapOvr>
-    <a:masterClrMapping/>
-  </p:clrMapOvr>
-</p:sld>
-</file>
-
-<file path=ppt/slides/slide12.xml><?xml version="1.0" encoding="utf-8"?>
 <p:sld xmlns:a="http://schemas.openxmlformats.org/drawingml/2006/main" xmlns:r="http://schemas.openxmlformats.org/officeDocument/2006/relationships" xmlns:p="http://schemas.openxmlformats.org/presentationml/2006/main">
   <p:cSld>
     <p:spTree>
@@ -6592,7 +6358,7 @@
 </p:sld>
 </file>
 
-<file path=ppt/slides/slide13.xml><?xml version="1.0" encoding="utf-8"?>
+<file path=ppt/slides/slide12.xml><?xml version="1.0" encoding="utf-8"?>
 <p:sld xmlns:a="http://schemas.openxmlformats.org/drawingml/2006/main" xmlns:r="http://schemas.openxmlformats.org/officeDocument/2006/relationships" xmlns:p="http://schemas.openxmlformats.org/presentationml/2006/main">
   <p:cSld>
     <p:spTree>
@@ -6622,7 +6388,7 @@
 </p:sld>
 </file>
 
-<file path=ppt/slides/slide14.xml><?xml version="1.0" encoding="utf-8"?>
+<file path=ppt/slides/slide13.xml><?xml version="1.0" encoding="utf-8"?>
 <p:sld xmlns:a="http://schemas.openxmlformats.org/drawingml/2006/main" xmlns:r="http://schemas.openxmlformats.org/officeDocument/2006/relationships" xmlns:p="http://schemas.openxmlformats.org/presentationml/2006/main">
   <p:cSld>
     <p:spTree>
@@ -7418,7 +7184,7 @@
 </p:sld>
 </file>
 
-<file path=ppt/slides/slide15.xml><?xml version="1.0" encoding="utf-8"?>
+<file path=ppt/slides/slide14.xml><?xml version="1.0" encoding="utf-8"?>
 <p:sld xmlns:a="http://schemas.openxmlformats.org/drawingml/2006/main" xmlns:r="http://schemas.openxmlformats.org/officeDocument/2006/relationships" xmlns:p="http://schemas.openxmlformats.org/presentationml/2006/main">
   <p:cSld>
     <p:spTree>
@@ -8167,7 +7933,7 @@
 </p:sld>
 </file>
 
-<file path=ppt/slides/slide16.xml><?xml version="1.0" encoding="utf-8"?>
+<file path=ppt/slides/slide15.xml><?xml version="1.0" encoding="utf-8"?>
 <p:sld xmlns:a="http://schemas.openxmlformats.org/drawingml/2006/main" xmlns:r="http://schemas.openxmlformats.org/officeDocument/2006/relationships" xmlns:p="http://schemas.openxmlformats.org/presentationml/2006/main">
   <p:cSld>
     <p:spTree>

</xml_diff>